<commit_message>
Restore original presentation filename plumetrace_presentation.pptx
</commit_message>
<xml_diff>
--- a/presentation/plumetrace_presentation.pptx
+++ b/presentation/plumetrace_presentation.pptx
@@ -4080,7 +4080,7 @@
         </p:nvSpPr>
         <p:spPr>
           <a:xfrm>
-            <a:off x="4663440" y="2057400"/>
+            <a:off x="4663440" y="2103120"/>
             <a:ext cx="6766560" cy="2743200"/>
           </a:xfrm>
           <a:prstGeom prst="rect">
@@ -4094,11 +4094,11 @@
           </a:bodyPr>
           <a:lstStyle/>
           <a:p>
-            <a:pPr>
+            <a:pPr algn="l">
               <a:spcAft>
                 <a:spcPts val="1400"/>
               </a:spcAft>
-              <a:defRPr sz="5600" b="1">
+              <a:defRPr sz="6400" b="1">
                 <a:solidFill>
                   <a:srgbClr val="219EBC"/>
                 </a:solidFill>
@@ -4110,8 +4110,8 @@
             </a:r>
           </a:p>
           <a:p>
-            <a:pPr>
-              <a:defRPr sz="2400" b="1">
+            <a:pPr algn="l">
+              <a:defRPr sz="2600" b="1">
                 <a:solidFill>
                   <a:srgbClr val="023047"/>
                 </a:solidFill>
@@ -4159,7 +4159,7 @@
         <p:spPr>
           <a:xfrm>
             <a:off x="731520" y="502920"/>
-            <a:ext cx="10728655" cy="777240"/>
+            <a:ext cx="10728655" cy="822960"/>
           </a:xfrm>
           <a:prstGeom prst="rect">
             <a:avLst/>
@@ -4172,8 +4172,8 @@
           </a:bodyPr>
           <a:lstStyle/>
           <a:p>
-            <a:pPr>
-              <a:defRPr sz="3600" b="1">
+            <a:pPr algn="l">
+              <a:defRPr sz="4000" b="1">
                 <a:solidFill>
                   <a:srgbClr val="023047"/>
                 </a:solidFill>
@@ -4195,10 +4195,12 @@
         <p:spPr>
           <a:xfrm>
             <a:off x="731520" y="1554480"/>
-            <a:ext cx="5180990" cy="2194560"/>
+            <a:ext cx="5180990" cy="2240280"/>
           </a:xfrm>
           <a:prstGeom prst="roundRect">
-            <a:avLst/>
+            <a:avLst>
+              <a:gd name="adj" fmla="val 3500"/>
+            </a:avLst>
           </a:prstGeom>
           <a:solidFill>
             <a:srgbClr val="F4F9FC"/>
@@ -4224,17 +4226,17 @@
           </a:fontRef>
         </p:style>
         <p:txBody>
-          <a:bodyPr rtlCol="0" anchor="t" wrap="square" lIns="256032" rIns="256032" tIns="201168" bIns="164592"/>
-          <a:lstStyle/>
-          <a:p>
-            <a:pPr algn="ctr">
+          <a:bodyPr rtlCol="0" anchor="t" wrap="square" lIns="320040" rIns="320040" tIns="274320" bIns="228600"/>
+          <a:lstStyle/>
+          <a:p>
+            <a:pPr algn="l">
               <a:spcBef>
                 <a:spcPts val="0"/>
               </a:spcBef>
               <a:spcAft>
-                <a:spcPts val="1000"/>
+                <a:spcPts val="1200"/>
               </a:spcAft>
-              <a:defRPr sz="1900" b="1">
+              <a:defRPr sz="2200" b="1">
                 <a:solidFill>
                   <a:srgbClr val="023047"/>
                 </a:solidFill>
@@ -4246,14 +4248,14 @@
             </a:r>
           </a:p>
           <a:p>
-            <a:pPr>
+            <a:pPr algn="l">
               <a:spcBef>
                 <a:spcPts val="0"/>
               </a:spcBef>
               <a:spcAft>
-                <a:spcPts val="600"/>
+                <a:spcPts val="900"/>
               </a:spcAft>
-              <a:defRPr sz="1400">
+              <a:defRPr sz="1600">
                 <a:solidFill>
                   <a:srgbClr val="023047"/>
                 </a:solidFill>
@@ -4265,14 +4267,14 @@
             </a:r>
           </a:p>
           <a:p>
-            <a:pPr>
+            <a:pPr algn="l">
               <a:spcBef>
                 <a:spcPts val="0"/>
               </a:spcBef>
               <a:spcAft>
-                <a:spcPts val="600"/>
+                <a:spcPts val="900"/>
               </a:spcAft>
-              <a:defRPr sz="1400">
+              <a:defRPr sz="1600">
                 <a:solidFill>
                   <a:srgbClr val="023047"/>
                 </a:solidFill>
@@ -4294,10 +4296,12 @@
         <p:spPr>
           <a:xfrm>
             <a:off x="6278270" y="1554480"/>
-            <a:ext cx="5180990" cy="2194560"/>
+            <a:ext cx="5180990" cy="2240280"/>
           </a:xfrm>
           <a:prstGeom prst="roundRect">
-            <a:avLst/>
+            <a:avLst>
+              <a:gd name="adj" fmla="val 3500"/>
+            </a:avLst>
           </a:prstGeom>
           <a:solidFill>
             <a:srgbClr val="F4F9FC"/>
@@ -4323,17 +4327,17 @@
           </a:fontRef>
         </p:style>
         <p:txBody>
-          <a:bodyPr rtlCol="0" anchor="t" wrap="square" lIns="256032" rIns="256032" tIns="201168" bIns="164592"/>
-          <a:lstStyle/>
-          <a:p>
-            <a:pPr algn="ctr">
+          <a:bodyPr rtlCol="0" anchor="t" wrap="square" lIns="320040" rIns="320040" tIns="274320" bIns="228600"/>
+          <a:lstStyle/>
+          <a:p>
+            <a:pPr algn="l">
               <a:spcBef>
                 <a:spcPts val="0"/>
               </a:spcBef>
               <a:spcAft>
-                <a:spcPts val="1000"/>
+                <a:spcPts val="1200"/>
               </a:spcAft>
-              <a:defRPr sz="1900" b="1">
+              <a:defRPr sz="2200" b="1">
                 <a:solidFill>
                   <a:srgbClr val="023047"/>
                 </a:solidFill>
@@ -4345,14 +4349,14 @@
             </a:r>
           </a:p>
           <a:p>
-            <a:pPr>
+            <a:pPr algn="l">
               <a:spcBef>
                 <a:spcPts val="0"/>
               </a:spcBef>
               <a:spcAft>
-                <a:spcPts val="600"/>
+                <a:spcPts val="900"/>
               </a:spcAft>
-              <a:defRPr sz="1400">
+              <a:defRPr sz="1600">
                 <a:solidFill>
                   <a:srgbClr val="023047"/>
                 </a:solidFill>
@@ -4364,14 +4368,14 @@
             </a:r>
           </a:p>
           <a:p>
-            <a:pPr>
+            <a:pPr algn="l">
               <a:spcBef>
                 <a:spcPts val="0"/>
               </a:spcBef>
               <a:spcAft>
-                <a:spcPts val="600"/>
+                <a:spcPts val="900"/>
               </a:spcAft>
-              <a:defRPr sz="1400">
+              <a:defRPr sz="1600">
                 <a:solidFill>
                   <a:srgbClr val="023047"/>
                 </a:solidFill>
@@ -4393,10 +4397,12 @@
         <p:spPr>
           <a:xfrm>
             <a:off x="731520" y="4069080"/>
-            <a:ext cx="5180990" cy="2194560"/>
+            <a:ext cx="5180990" cy="2240280"/>
           </a:xfrm>
           <a:prstGeom prst="roundRect">
-            <a:avLst/>
+            <a:avLst>
+              <a:gd name="adj" fmla="val 3500"/>
+            </a:avLst>
           </a:prstGeom>
           <a:solidFill>
             <a:srgbClr val="F4F9FC"/>
@@ -4422,17 +4428,17 @@
           </a:fontRef>
         </p:style>
         <p:txBody>
-          <a:bodyPr rtlCol="0" anchor="t" wrap="square" lIns="256032" rIns="256032" tIns="201168" bIns="164592"/>
-          <a:lstStyle/>
-          <a:p>
-            <a:pPr algn="ctr">
+          <a:bodyPr rtlCol="0" anchor="t" wrap="square" lIns="320040" rIns="320040" tIns="274320" bIns="228600"/>
+          <a:lstStyle/>
+          <a:p>
+            <a:pPr algn="l">
               <a:spcBef>
                 <a:spcPts val="0"/>
               </a:spcBef>
               <a:spcAft>
-                <a:spcPts val="1000"/>
+                <a:spcPts val="1200"/>
               </a:spcAft>
-              <a:defRPr sz="1900" b="1">
+              <a:defRPr sz="2200" b="1">
                 <a:solidFill>
                   <a:srgbClr val="023047"/>
                 </a:solidFill>
@@ -4444,14 +4450,14 @@
             </a:r>
           </a:p>
           <a:p>
-            <a:pPr>
+            <a:pPr algn="l">
               <a:spcBef>
                 <a:spcPts val="0"/>
               </a:spcBef>
               <a:spcAft>
-                <a:spcPts val="600"/>
+                <a:spcPts val="900"/>
               </a:spcAft>
-              <a:defRPr sz="1400">
+              <a:defRPr sz="1600">
                 <a:solidFill>
                   <a:srgbClr val="023047"/>
                 </a:solidFill>
@@ -4463,14 +4469,14 @@
             </a:r>
           </a:p>
           <a:p>
-            <a:pPr>
+            <a:pPr algn="l">
               <a:spcBef>
                 <a:spcPts val="0"/>
               </a:spcBef>
               <a:spcAft>
-                <a:spcPts val="600"/>
+                <a:spcPts val="900"/>
               </a:spcAft>
-              <a:defRPr sz="1400">
+              <a:defRPr sz="1600">
                 <a:solidFill>
                   <a:srgbClr val="023047"/>
                 </a:solidFill>
@@ -4492,10 +4498,12 @@
         <p:spPr>
           <a:xfrm>
             <a:off x="6278270" y="4069080"/>
-            <a:ext cx="5180990" cy="2194560"/>
+            <a:ext cx="5180990" cy="2240280"/>
           </a:xfrm>
           <a:prstGeom prst="roundRect">
-            <a:avLst/>
+            <a:avLst>
+              <a:gd name="adj" fmla="val 3500"/>
+            </a:avLst>
           </a:prstGeom>
           <a:solidFill>
             <a:srgbClr val="F4F9FC"/>
@@ -4521,17 +4529,17 @@
           </a:fontRef>
         </p:style>
         <p:txBody>
-          <a:bodyPr rtlCol="0" anchor="t" wrap="square" lIns="256032" rIns="256032" tIns="201168" bIns="164592"/>
-          <a:lstStyle/>
-          <a:p>
-            <a:pPr algn="ctr">
+          <a:bodyPr rtlCol="0" anchor="t" wrap="square" lIns="320040" rIns="320040" tIns="274320" bIns="228600"/>
+          <a:lstStyle/>
+          <a:p>
+            <a:pPr algn="l">
               <a:spcBef>
                 <a:spcPts val="0"/>
               </a:spcBef>
               <a:spcAft>
-                <a:spcPts val="1000"/>
+                <a:spcPts val="1200"/>
               </a:spcAft>
-              <a:defRPr sz="1900" b="1">
+              <a:defRPr sz="2200" b="1">
                 <a:solidFill>
                   <a:srgbClr val="023047"/>
                 </a:solidFill>
@@ -4543,14 +4551,14 @@
             </a:r>
           </a:p>
           <a:p>
-            <a:pPr>
+            <a:pPr algn="l">
               <a:spcBef>
                 <a:spcPts val="0"/>
               </a:spcBef>
               <a:spcAft>
-                <a:spcPts val="600"/>
+                <a:spcPts val="900"/>
               </a:spcAft>
-              <a:defRPr sz="1400">
+              <a:defRPr sz="1600">
                 <a:solidFill>
                   <a:srgbClr val="023047"/>
                 </a:solidFill>
@@ -4562,14 +4570,14 @@
             </a:r>
           </a:p>
           <a:p>
-            <a:pPr>
+            <a:pPr algn="l">
               <a:spcBef>
                 <a:spcPts val="0"/>
               </a:spcBef>
               <a:spcAft>
-                <a:spcPts val="600"/>
+                <a:spcPts val="900"/>
               </a:spcAft>
-              <a:defRPr sz="1400">
+              <a:defRPr sz="1600">
                 <a:solidFill>
                   <a:srgbClr val="023047"/>
                 </a:solidFill>
@@ -4617,7 +4625,7 @@
         <p:spPr>
           <a:xfrm>
             <a:off x="731520" y="502920"/>
-            <a:ext cx="10728655" cy="777240"/>
+            <a:ext cx="10728655" cy="822960"/>
           </a:xfrm>
           <a:prstGeom prst="rect">
             <a:avLst/>
@@ -4630,8 +4638,8 @@
           </a:bodyPr>
           <a:lstStyle/>
           <a:p>
-            <a:pPr>
-              <a:defRPr sz="3600" b="1">
+            <a:pPr algn="l">
+              <a:defRPr sz="4000" b="1">
                 <a:solidFill>
                   <a:srgbClr val="023047"/>
                 </a:solidFill>
@@ -4652,11 +4660,13 @@
         </p:nvSpPr>
         <p:spPr>
           <a:xfrm>
-            <a:off x="731520" y="1508760"/>
-            <a:ext cx="5180990" cy="3840480"/>
+            <a:off x="731520" y="1554480"/>
+            <a:ext cx="5180990" cy="3794760"/>
           </a:xfrm>
           <a:prstGeom prst="roundRect">
-            <a:avLst/>
+            <a:avLst>
+              <a:gd name="adj" fmla="val 3500"/>
+            </a:avLst>
           </a:prstGeom>
           <a:solidFill>
             <a:srgbClr val="F4F9FC"/>
@@ -4682,17 +4692,17 @@
           </a:fontRef>
         </p:style>
         <p:txBody>
-          <a:bodyPr rtlCol="0" anchor="t" wrap="square" lIns="256032" rIns="256032" tIns="201168" bIns="164592"/>
-          <a:lstStyle/>
-          <a:p>
-            <a:pPr algn="ctr">
+          <a:bodyPr rtlCol="0" anchor="t" wrap="square" lIns="320040" rIns="320040" tIns="274320" bIns="228600"/>
+          <a:lstStyle/>
+          <a:p>
+            <a:pPr algn="l">
               <a:spcBef>
                 <a:spcPts val="0"/>
               </a:spcBef>
               <a:spcAft>
                 <a:spcPts val="400"/>
               </a:spcAft>
-              <a:defRPr sz="1900" b="1">
+              <a:defRPr sz="2300" b="1">
                 <a:solidFill>
                   <a:srgbClr val="023047"/>
                 </a:solidFill>
@@ -4704,14 +4714,14 @@
             </a:r>
           </a:p>
           <a:p>
-            <a:pPr>
+            <a:pPr algn="l">
               <a:spcBef>
                 <a:spcPts val="0"/>
               </a:spcBef>
               <a:spcAft>
-                <a:spcPts val="1000"/>
+                <a:spcPts val="1400"/>
               </a:spcAft>
-              <a:defRPr sz="1300" b="1">
+              <a:defRPr sz="1400" b="1">
                 <a:solidFill>
                   <a:srgbClr val="219EBC"/>
                 </a:solidFill>
@@ -4723,14 +4733,14 @@
             </a:r>
           </a:p>
           <a:p>
-            <a:pPr>
+            <a:pPr algn="l">
               <a:spcBef>
                 <a:spcPts val="0"/>
               </a:spcBef>
               <a:spcAft>
-                <a:spcPts val="600"/>
+                <a:spcPts val="900"/>
               </a:spcAft>
-              <a:defRPr sz="1400">
+              <a:defRPr sz="1700">
                 <a:solidFill>
                   <a:srgbClr val="023047"/>
                 </a:solidFill>
@@ -4742,14 +4752,14 @@
             </a:r>
           </a:p>
           <a:p>
-            <a:pPr>
+            <a:pPr algn="l">
               <a:spcBef>
                 <a:spcPts val="0"/>
               </a:spcBef>
               <a:spcAft>
-                <a:spcPts val="600"/>
+                <a:spcPts val="900"/>
               </a:spcAft>
-              <a:defRPr sz="1400">
+              <a:defRPr sz="1700">
                 <a:solidFill>
                   <a:srgbClr val="023047"/>
                 </a:solidFill>
@@ -4761,14 +4771,14 @@
             </a:r>
           </a:p>
           <a:p>
-            <a:pPr>
+            <a:pPr algn="l">
               <a:spcBef>
                 <a:spcPts val="0"/>
               </a:spcBef>
               <a:spcAft>
-                <a:spcPts val="600"/>
+                <a:spcPts val="900"/>
               </a:spcAft>
-              <a:defRPr sz="1400">
+              <a:defRPr sz="1700">
                 <a:solidFill>
                   <a:srgbClr val="023047"/>
                 </a:solidFill>
@@ -4789,11 +4799,13 @@
         </p:nvSpPr>
         <p:spPr>
           <a:xfrm>
-            <a:off x="6278270" y="1508760"/>
-            <a:ext cx="5180990" cy="3840480"/>
+            <a:off x="6278270" y="1554480"/>
+            <a:ext cx="5180990" cy="3794760"/>
           </a:xfrm>
           <a:prstGeom prst="roundRect">
-            <a:avLst/>
+            <a:avLst>
+              <a:gd name="adj" fmla="val 3500"/>
+            </a:avLst>
           </a:prstGeom>
           <a:solidFill>
             <a:srgbClr val="F4F9FC"/>
@@ -4819,17 +4831,17 @@
           </a:fontRef>
         </p:style>
         <p:txBody>
-          <a:bodyPr rtlCol="0" anchor="t" wrap="square" lIns="256032" rIns="256032" tIns="201168" bIns="164592"/>
-          <a:lstStyle/>
-          <a:p>
-            <a:pPr algn="ctr">
+          <a:bodyPr rtlCol="0" anchor="t" wrap="square" lIns="320040" rIns="320040" tIns="274320" bIns="228600"/>
+          <a:lstStyle/>
+          <a:p>
+            <a:pPr algn="l">
               <a:spcBef>
                 <a:spcPts val="0"/>
               </a:spcBef>
               <a:spcAft>
-                <a:spcPts val="1000"/>
+                <a:spcPts val="1200"/>
               </a:spcAft>
-              <a:defRPr sz="1900" b="1">
+              <a:defRPr sz="2300" b="1">
                 <a:solidFill>
                   <a:srgbClr val="023047"/>
                 </a:solidFill>
@@ -4841,14 +4853,14 @@
             </a:r>
           </a:p>
           <a:p>
-            <a:pPr>
+            <a:pPr algn="l">
               <a:spcBef>
                 <a:spcPts val="0"/>
               </a:spcBef>
               <a:spcAft>
-                <a:spcPts val="600"/>
+                <a:spcPts val="900"/>
               </a:spcAft>
-              <a:defRPr sz="1400">
+              <a:defRPr sz="1700">
                 <a:solidFill>
                   <a:srgbClr val="023047"/>
                 </a:solidFill>
@@ -4860,14 +4872,14 @@
             </a:r>
           </a:p>
           <a:p>
-            <a:pPr>
+            <a:pPr algn="l">
               <a:spcBef>
                 <a:spcPts val="0"/>
               </a:spcBef>
               <a:spcAft>
-                <a:spcPts val="600"/>
+                <a:spcPts val="900"/>
               </a:spcAft>
-              <a:defRPr sz="1400">
+              <a:defRPr sz="1700">
                 <a:solidFill>
                   <a:srgbClr val="023047"/>
                 </a:solidFill>
@@ -4879,14 +4891,14 @@
             </a:r>
           </a:p>
           <a:p>
-            <a:pPr>
+            <a:pPr algn="l">
               <a:spcBef>
                 <a:spcPts val="0"/>
               </a:spcBef>
               <a:spcAft>
-                <a:spcPts val="600"/>
+                <a:spcPts val="900"/>
               </a:spcAft>
-              <a:defRPr sz="1400">
+              <a:defRPr sz="1700">
                 <a:solidFill>
                   <a:srgbClr val="023047"/>
                 </a:solidFill>
@@ -4907,11 +4919,13 @@
         </p:nvSpPr>
         <p:spPr>
           <a:xfrm>
-            <a:off x="731520" y="5623560"/>
+            <a:off x="731520" y="5577840"/>
             <a:ext cx="10728655" cy="685800"/>
           </a:xfrm>
           <a:prstGeom prst="roundRect">
-            <a:avLst/>
+            <a:avLst>
+              <a:gd name="adj" fmla="val 3500"/>
+            </a:avLst>
           </a:prstGeom>
           <a:solidFill>
             <a:srgbClr val="F4F9FC"/>
@@ -4937,11 +4951,11 @@
           </a:fontRef>
         </p:style>
         <p:txBody>
-          <a:bodyPr rtlCol="0" anchor="ctr" wrap="square" lIns="274320" tIns="91440"/>
-          <a:lstStyle/>
-          <a:p>
-            <a:pPr algn="ctr">
-              <a:defRPr sz="1600" b="1">
+          <a:bodyPr rtlCol="0" anchor="ctr" wrap="square" lIns="320040" rIns="320040" tIns="91440"/>
+          <a:lstStyle/>
+          <a:p>
+            <a:pPr algn="l">
+              <a:defRPr sz="1800" b="1">
                 <a:solidFill>
                   <a:srgbClr val="FB8500"/>
                 </a:solidFill>
@@ -4952,7 +4966,7 @@
               <a:t>The Result:  </a:t>
             </a:r>
             <a:r>
-              <a:rPr sz="1600" b="1">
+              <a:rPr sz="1800" b="1">
                 <a:solidFill>
                   <a:srgbClr val="023047"/>
                 </a:solidFill>
@@ -4998,7 +5012,7 @@
         <p:spPr>
           <a:xfrm>
             <a:off x="731520" y="502920"/>
-            <a:ext cx="10728655" cy="777240"/>
+            <a:ext cx="10728655" cy="822960"/>
           </a:xfrm>
           <a:prstGeom prst="rect">
             <a:avLst/>
@@ -5011,8 +5025,8 @@
           </a:bodyPr>
           <a:lstStyle/>
           <a:p>
-            <a:pPr>
-              <a:defRPr sz="3600" b="1">
+            <a:pPr algn="l">
+              <a:defRPr sz="4000" b="1">
                 <a:solidFill>
                   <a:srgbClr val="023047"/>
                 </a:solidFill>
@@ -5033,11 +5047,13 @@
         </p:nvSpPr>
         <p:spPr>
           <a:xfrm>
-            <a:off x="731520" y="1508760"/>
-            <a:ext cx="5180990" cy="4663440"/>
+            <a:off x="731520" y="1554480"/>
+            <a:ext cx="5180990" cy="4709160"/>
           </a:xfrm>
           <a:prstGeom prst="roundRect">
-            <a:avLst/>
+            <a:avLst>
+              <a:gd name="adj" fmla="val 3500"/>
+            </a:avLst>
           </a:prstGeom>
           <a:solidFill>
             <a:srgbClr val="F4F9FC"/>
@@ -5063,17 +5079,17 @@
           </a:fontRef>
         </p:style>
         <p:txBody>
-          <a:bodyPr rtlCol="0" anchor="t" wrap="square" lIns="256032" rIns="256032" tIns="201168" bIns="164592"/>
-          <a:lstStyle/>
-          <a:p>
-            <a:pPr algn="ctr">
+          <a:bodyPr rtlCol="0" anchor="t" wrap="square" lIns="320040" rIns="320040" tIns="274320" bIns="228600"/>
+          <a:lstStyle/>
+          <a:p>
+            <a:pPr algn="l">
               <a:spcBef>
                 <a:spcPts val="0"/>
               </a:spcBef>
               <a:spcAft>
-                <a:spcPts val="1000"/>
+                <a:spcPts val="1200"/>
               </a:spcAft>
-              <a:defRPr sz="1900" b="1">
+              <a:defRPr sz="2300" b="1">
                 <a:solidFill>
                   <a:srgbClr val="023047"/>
                 </a:solidFill>
@@ -5085,14 +5101,14 @@
             </a:r>
           </a:p>
           <a:p>
-            <a:pPr>
+            <a:pPr algn="l">
               <a:spcBef>
                 <a:spcPts val="0"/>
               </a:spcBef>
               <a:spcAft>
-                <a:spcPts val="600"/>
+                <a:spcPts val="900"/>
               </a:spcAft>
-              <a:defRPr sz="1400">
+              <a:defRPr sz="1700">
                 <a:solidFill>
                   <a:srgbClr val="023047"/>
                 </a:solidFill>
@@ -5104,14 +5120,14 @@
             </a:r>
           </a:p>
           <a:p>
-            <a:pPr>
+            <a:pPr algn="l">
               <a:spcBef>
                 <a:spcPts val="0"/>
               </a:spcBef>
               <a:spcAft>
-                <a:spcPts val="600"/>
+                <a:spcPts val="900"/>
               </a:spcAft>
-              <a:defRPr sz="1400">
+              <a:defRPr sz="1700">
                 <a:solidFill>
                   <a:srgbClr val="023047"/>
                 </a:solidFill>
@@ -5123,14 +5139,14 @@
             </a:r>
           </a:p>
           <a:p>
-            <a:pPr>
+            <a:pPr algn="l">
               <a:spcBef>
                 <a:spcPts val="0"/>
               </a:spcBef>
               <a:spcAft>
-                <a:spcPts val="600"/>
+                <a:spcPts val="900"/>
               </a:spcAft>
-              <a:defRPr sz="1400">
+              <a:defRPr sz="1700">
                 <a:solidFill>
                   <a:srgbClr val="023047"/>
                 </a:solidFill>
@@ -5142,14 +5158,14 @@
             </a:r>
           </a:p>
           <a:p>
-            <a:pPr>
+            <a:pPr algn="l">
               <a:spcBef>
                 <a:spcPts val="0"/>
               </a:spcBef>
               <a:spcAft>
-                <a:spcPts val="600"/>
+                <a:spcPts val="900"/>
               </a:spcAft>
-              <a:defRPr sz="1400">
+              <a:defRPr sz="1700">
                 <a:solidFill>
                   <a:srgbClr val="023047"/>
                 </a:solidFill>
@@ -5170,11 +5186,13 @@
         </p:nvSpPr>
         <p:spPr>
           <a:xfrm>
-            <a:off x="6278270" y="1508760"/>
-            <a:ext cx="5180990" cy="4663440"/>
+            <a:off x="6278270" y="1554480"/>
+            <a:ext cx="5180990" cy="4709160"/>
           </a:xfrm>
           <a:prstGeom prst="roundRect">
-            <a:avLst/>
+            <a:avLst>
+              <a:gd name="adj" fmla="val 3500"/>
+            </a:avLst>
           </a:prstGeom>
           <a:solidFill>
             <a:srgbClr val="F4F9FC"/>
@@ -5200,17 +5218,17 @@
           </a:fontRef>
         </p:style>
         <p:txBody>
-          <a:bodyPr rtlCol="0" anchor="t" wrap="square" lIns="256032" rIns="256032" tIns="201168" bIns="164592"/>
-          <a:lstStyle/>
-          <a:p>
-            <a:pPr algn="ctr">
+          <a:bodyPr rtlCol="0" anchor="t" wrap="square" lIns="320040" rIns="320040" tIns="274320" bIns="228600"/>
+          <a:lstStyle/>
+          <a:p>
+            <a:pPr algn="l">
               <a:spcBef>
                 <a:spcPts val="0"/>
               </a:spcBef>
               <a:spcAft>
-                <a:spcPts val="1000"/>
+                <a:spcPts val="1200"/>
               </a:spcAft>
-              <a:defRPr sz="1900" b="1">
+              <a:defRPr sz="2300" b="1">
                 <a:solidFill>
                   <a:srgbClr val="023047"/>
                 </a:solidFill>
@@ -5222,14 +5240,14 @@
             </a:r>
           </a:p>
           <a:p>
-            <a:pPr>
+            <a:pPr algn="l">
               <a:spcBef>
                 <a:spcPts val="0"/>
               </a:spcBef>
               <a:spcAft>
-                <a:spcPts val="600"/>
+                <a:spcPts val="900"/>
               </a:spcAft>
-              <a:defRPr sz="1400">
+              <a:defRPr sz="1700">
                 <a:solidFill>
                   <a:srgbClr val="023047"/>
                 </a:solidFill>
@@ -5241,14 +5259,14 @@
             </a:r>
           </a:p>
           <a:p>
-            <a:pPr>
+            <a:pPr algn="l">
               <a:spcBef>
                 <a:spcPts val="0"/>
               </a:spcBef>
               <a:spcAft>
-                <a:spcPts val="600"/>
+                <a:spcPts val="900"/>
               </a:spcAft>
-              <a:defRPr sz="1400">
+              <a:defRPr sz="1700">
                 <a:solidFill>
                   <a:srgbClr val="023047"/>
                 </a:solidFill>
@@ -5260,14 +5278,14 @@
             </a:r>
           </a:p>
           <a:p>
-            <a:pPr>
+            <a:pPr algn="l">
               <a:spcBef>
                 <a:spcPts val="0"/>
               </a:spcBef>
               <a:spcAft>
-                <a:spcPts val="600"/>
+                <a:spcPts val="900"/>
               </a:spcAft>
-              <a:defRPr sz="1400">
+              <a:defRPr sz="1700">
                 <a:solidFill>
                   <a:srgbClr val="023047"/>
                 </a:solidFill>
@@ -5279,14 +5297,14 @@
             </a:r>
           </a:p>
           <a:p>
-            <a:pPr>
+            <a:pPr algn="l">
               <a:spcBef>
                 <a:spcPts val="0"/>
               </a:spcBef>
               <a:spcAft>
-                <a:spcPts val="600"/>
+                <a:spcPts val="900"/>
               </a:spcAft>
-              <a:defRPr sz="1400">
+              <a:defRPr sz="1700">
                 <a:solidFill>
                   <a:srgbClr val="023047"/>
                 </a:solidFill>
@@ -5334,7 +5352,7 @@
         <p:spPr>
           <a:xfrm>
             <a:off x="731520" y="502920"/>
-            <a:ext cx="10728655" cy="777240"/>
+            <a:ext cx="10728655" cy="822960"/>
           </a:xfrm>
           <a:prstGeom prst="rect">
             <a:avLst/>
@@ -5347,8 +5365,8 @@
           </a:bodyPr>
           <a:lstStyle/>
           <a:p>
-            <a:pPr>
-              <a:defRPr sz="3600" b="1">
+            <a:pPr algn="l">
+              <a:defRPr sz="4000" b="1">
                 <a:solidFill>
                   <a:srgbClr val="023047"/>
                 </a:solidFill>
@@ -5369,11 +5387,13 @@
         </p:nvSpPr>
         <p:spPr>
           <a:xfrm>
-            <a:off x="731520" y="1508760"/>
-            <a:ext cx="3332073" cy="4663440"/>
+            <a:off x="731520" y="1554480"/>
+            <a:ext cx="3332073" cy="4709160"/>
           </a:xfrm>
           <a:prstGeom prst="roundRect">
-            <a:avLst/>
+            <a:avLst>
+              <a:gd name="adj" fmla="val 3500"/>
+            </a:avLst>
           </a:prstGeom>
           <a:solidFill>
             <a:srgbClr val="F4F9FC"/>
@@ -5399,17 +5419,17 @@
           </a:fontRef>
         </p:style>
         <p:txBody>
-          <a:bodyPr rtlCol="0" anchor="t" wrap="square" lIns="256032" rIns="256032" tIns="201168" bIns="164592"/>
-          <a:lstStyle/>
-          <a:p>
-            <a:pPr algn="ctr">
+          <a:bodyPr rtlCol="0" anchor="t" wrap="square" lIns="320040" rIns="320040" tIns="274320" bIns="228600"/>
+          <a:lstStyle/>
+          <a:p>
+            <a:pPr algn="l">
               <a:spcBef>
                 <a:spcPts val="0"/>
               </a:spcBef>
               <a:spcAft>
-                <a:spcPts val="1000"/>
+                <a:spcPts val="1200"/>
               </a:spcAft>
-              <a:defRPr sz="1900" b="1">
+              <a:defRPr sz="2100" b="1">
                 <a:solidFill>
                   <a:srgbClr val="023047"/>
                 </a:solidFill>
@@ -5421,14 +5441,14 @@
             </a:r>
           </a:p>
           <a:p>
-            <a:pPr>
+            <a:pPr algn="l">
               <a:spcBef>
                 <a:spcPts val="0"/>
               </a:spcBef>
               <a:spcAft>
-                <a:spcPts val="600"/>
+                <a:spcPts val="900"/>
               </a:spcAft>
-              <a:defRPr sz="1400">
+              <a:defRPr sz="1500">
                 <a:solidFill>
                   <a:srgbClr val="023047"/>
                 </a:solidFill>
@@ -5440,14 +5460,14 @@
             </a:r>
           </a:p>
           <a:p>
-            <a:pPr>
+            <a:pPr algn="l">
               <a:spcBef>
                 <a:spcPts val="0"/>
               </a:spcBef>
               <a:spcAft>
-                <a:spcPts val="600"/>
+                <a:spcPts val="900"/>
               </a:spcAft>
-              <a:defRPr sz="1400">
+              <a:defRPr sz="1500">
                 <a:solidFill>
                   <a:srgbClr val="023047"/>
                 </a:solidFill>
@@ -5459,14 +5479,14 @@
             </a:r>
           </a:p>
           <a:p>
-            <a:pPr>
+            <a:pPr algn="l">
               <a:spcBef>
                 <a:spcPts val="0"/>
               </a:spcBef>
               <a:spcAft>
-                <a:spcPts val="600"/>
+                <a:spcPts val="900"/>
               </a:spcAft>
-              <a:defRPr sz="1400">
+              <a:defRPr sz="1500">
                 <a:solidFill>
                   <a:srgbClr val="023047"/>
                 </a:solidFill>
@@ -5478,14 +5498,14 @@
             </a:r>
           </a:p>
           <a:p>
-            <a:pPr>
+            <a:pPr algn="l">
               <a:spcBef>
                 <a:spcPts val="0"/>
               </a:spcBef>
               <a:spcAft>
-                <a:spcPts val="600"/>
+                <a:spcPts val="900"/>
               </a:spcAft>
-              <a:defRPr sz="1400">
+              <a:defRPr sz="1500">
                 <a:solidFill>
                   <a:srgbClr val="023047"/>
                 </a:solidFill>
@@ -5506,11 +5526,13 @@
         </p:nvSpPr>
         <p:spPr>
           <a:xfrm>
-            <a:off x="4429353" y="1508760"/>
-            <a:ext cx="3332073" cy="4663440"/>
+            <a:off x="4429353" y="1554480"/>
+            <a:ext cx="3332073" cy="4709160"/>
           </a:xfrm>
           <a:prstGeom prst="roundRect">
-            <a:avLst/>
+            <a:avLst>
+              <a:gd name="adj" fmla="val 3500"/>
+            </a:avLst>
           </a:prstGeom>
           <a:solidFill>
             <a:srgbClr val="F4F9FC"/>
@@ -5536,17 +5558,17 @@
           </a:fontRef>
         </p:style>
         <p:txBody>
-          <a:bodyPr rtlCol="0" anchor="t" wrap="square" lIns="256032" rIns="256032" tIns="201168" bIns="164592"/>
-          <a:lstStyle/>
-          <a:p>
-            <a:pPr algn="ctr">
+          <a:bodyPr rtlCol="0" anchor="t" wrap="square" lIns="320040" rIns="320040" tIns="274320" bIns="228600"/>
+          <a:lstStyle/>
+          <a:p>
+            <a:pPr algn="l">
               <a:spcBef>
                 <a:spcPts val="0"/>
               </a:spcBef>
               <a:spcAft>
-                <a:spcPts val="1000"/>
+                <a:spcPts val="1200"/>
               </a:spcAft>
-              <a:defRPr sz="1900" b="1">
+              <a:defRPr sz="2100" b="1">
                 <a:solidFill>
                   <a:srgbClr val="023047"/>
                 </a:solidFill>
@@ -5558,14 +5580,14 @@
             </a:r>
           </a:p>
           <a:p>
-            <a:pPr>
+            <a:pPr algn="l">
               <a:spcBef>
                 <a:spcPts val="0"/>
               </a:spcBef>
               <a:spcAft>
-                <a:spcPts val="600"/>
+                <a:spcPts val="900"/>
               </a:spcAft>
-              <a:defRPr sz="1400">
+              <a:defRPr sz="1500">
                 <a:solidFill>
                   <a:srgbClr val="023047"/>
                 </a:solidFill>
@@ -5577,14 +5599,14 @@
             </a:r>
           </a:p>
           <a:p>
-            <a:pPr>
+            <a:pPr algn="l">
               <a:spcBef>
                 <a:spcPts val="0"/>
               </a:spcBef>
               <a:spcAft>
-                <a:spcPts val="600"/>
+                <a:spcPts val="900"/>
               </a:spcAft>
-              <a:defRPr sz="1400">
+              <a:defRPr sz="1500">
                 <a:solidFill>
                   <a:srgbClr val="023047"/>
                 </a:solidFill>
@@ -5596,14 +5618,14 @@
             </a:r>
           </a:p>
           <a:p>
-            <a:pPr>
+            <a:pPr algn="l">
               <a:spcBef>
                 <a:spcPts val="0"/>
               </a:spcBef>
               <a:spcAft>
-                <a:spcPts val="600"/>
+                <a:spcPts val="900"/>
               </a:spcAft>
-              <a:defRPr sz="1400">
+              <a:defRPr sz="1500">
                 <a:solidFill>
                   <a:srgbClr val="023047"/>
                 </a:solidFill>
@@ -5615,14 +5637,14 @@
             </a:r>
           </a:p>
           <a:p>
-            <a:pPr>
+            <a:pPr algn="l">
               <a:spcBef>
                 <a:spcPts val="0"/>
               </a:spcBef>
               <a:spcAft>
-                <a:spcPts val="600"/>
+                <a:spcPts val="900"/>
               </a:spcAft>
-              <a:defRPr sz="1400">
+              <a:defRPr sz="1500">
                 <a:solidFill>
                   <a:srgbClr val="023047"/>
                 </a:solidFill>
@@ -5643,11 +5665,13 @@
         </p:nvSpPr>
         <p:spPr>
           <a:xfrm>
-            <a:off x="8127186" y="1508760"/>
-            <a:ext cx="3332073" cy="4663440"/>
+            <a:off x="8127186" y="1554480"/>
+            <a:ext cx="3332073" cy="4709160"/>
           </a:xfrm>
           <a:prstGeom prst="roundRect">
-            <a:avLst/>
+            <a:avLst>
+              <a:gd name="adj" fmla="val 3500"/>
+            </a:avLst>
           </a:prstGeom>
           <a:solidFill>
             <a:srgbClr val="F4F9FC"/>
@@ -5673,17 +5697,17 @@
           </a:fontRef>
         </p:style>
         <p:txBody>
-          <a:bodyPr rtlCol="0" anchor="t" wrap="square" lIns="256032" rIns="256032" tIns="201168" bIns="164592"/>
-          <a:lstStyle/>
-          <a:p>
-            <a:pPr algn="ctr">
+          <a:bodyPr rtlCol="0" anchor="t" wrap="square" lIns="320040" rIns="320040" tIns="274320" bIns="228600"/>
+          <a:lstStyle/>
+          <a:p>
+            <a:pPr algn="l">
               <a:spcBef>
                 <a:spcPts val="0"/>
               </a:spcBef>
               <a:spcAft>
-                <a:spcPts val="1000"/>
+                <a:spcPts val="1200"/>
               </a:spcAft>
-              <a:defRPr sz="1900" b="1">
+              <a:defRPr sz="2100" b="1">
                 <a:solidFill>
                   <a:srgbClr val="023047"/>
                 </a:solidFill>
@@ -5695,14 +5719,14 @@
             </a:r>
           </a:p>
           <a:p>
-            <a:pPr>
+            <a:pPr algn="l">
               <a:spcBef>
                 <a:spcPts val="0"/>
               </a:spcBef>
               <a:spcAft>
-                <a:spcPts val="600"/>
+                <a:spcPts val="900"/>
               </a:spcAft>
-              <a:defRPr sz="1400">
+              <a:defRPr sz="1500">
                 <a:solidFill>
                   <a:srgbClr val="023047"/>
                 </a:solidFill>
@@ -5714,14 +5738,14 @@
             </a:r>
           </a:p>
           <a:p>
-            <a:pPr>
+            <a:pPr algn="l">
               <a:spcBef>
                 <a:spcPts val="0"/>
               </a:spcBef>
               <a:spcAft>
-                <a:spcPts val="600"/>
+                <a:spcPts val="900"/>
               </a:spcAft>
-              <a:defRPr sz="1400">
+              <a:defRPr sz="1500">
                 <a:solidFill>
                   <a:srgbClr val="023047"/>
                 </a:solidFill>
@@ -5733,14 +5757,14 @@
             </a:r>
           </a:p>
           <a:p>
-            <a:pPr>
+            <a:pPr algn="l">
               <a:spcBef>
                 <a:spcPts val="0"/>
               </a:spcBef>
               <a:spcAft>
-                <a:spcPts val="600"/>
+                <a:spcPts val="900"/>
               </a:spcAft>
-              <a:defRPr sz="1400">
+              <a:defRPr sz="1500">
                 <a:solidFill>
                   <a:srgbClr val="023047"/>
                 </a:solidFill>
@@ -5752,14 +5776,14 @@
             </a:r>
           </a:p>
           <a:p>
-            <a:pPr>
+            <a:pPr algn="l">
               <a:spcBef>
                 <a:spcPts val="0"/>
               </a:spcBef>
               <a:spcAft>
-                <a:spcPts val="600"/>
+                <a:spcPts val="900"/>
               </a:spcAft>
-              <a:defRPr sz="1400">
+              <a:defRPr sz="1500">
                 <a:solidFill>
                   <a:srgbClr val="023047"/>
                 </a:solidFill>
@@ -5807,7 +5831,7 @@
         <p:spPr>
           <a:xfrm>
             <a:off x="731520" y="502920"/>
-            <a:ext cx="10728655" cy="777240"/>
+            <a:ext cx="10728655" cy="822960"/>
           </a:xfrm>
           <a:prstGeom prst="rect">
             <a:avLst/>
@@ -5820,8 +5844,8 @@
           </a:bodyPr>
           <a:lstStyle/>
           <a:p>
-            <a:pPr>
-              <a:defRPr sz="3600" b="1">
+            <a:pPr algn="l">
+              <a:defRPr sz="4000" b="1">
                 <a:solidFill>
                   <a:srgbClr val="023047"/>
                 </a:solidFill>
@@ -5842,11 +5866,13 @@
         </p:nvSpPr>
         <p:spPr>
           <a:xfrm>
-            <a:off x="731520" y="1508760"/>
-            <a:ext cx="5180990" cy="4663440"/>
+            <a:off x="731520" y="1554480"/>
+            <a:ext cx="5180990" cy="4709160"/>
           </a:xfrm>
           <a:prstGeom prst="roundRect">
-            <a:avLst/>
+            <a:avLst>
+              <a:gd name="adj" fmla="val 3500"/>
+            </a:avLst>
           </a:prstGeom>
           <a:solidFill>
             <a:srgbClr val="F4F9FC"/>
@@ -5872,17 +5898,17 @@
           </a:fontRef>
         </p:style>
         <p:txBody>
-          <a:bodyPr rtlCol="0" anchor="t" wrap="square" lIns="256032" rIns="256032" tIns="201168" bIns="164592"/>
-          <a:lstStyle/>
-          <a:p>
-            <a:pPr algn="ctr">
+          <a:bodyPr rtlCol="0" anchor="t" wrap="square" lIns="320040" rIns="320040" tIns="274320" bIns="228600"/>
+          <a:lstStyle/>
+          <a:p>
+            <a:pPr algn="l">
               <a:spcBef>
                 <a:spcPts val="0"/>
               </a:spcBef>
               <a:spcAft>
-                <a:spcPts val="1000"/>
+                <a:spcPts val="1200"/>
               </a:spcAft>
-              <a:defRPr sz="1900" b="1">
+              <a:defRPr sz="2300" b="1">
                 <a:solidFill>
                   <a:srgbClr val="023047"/>
                 </a:solidFill>
@@ -5894,14 +5920,14 @@
             </a:r>
           </a:p>
           <a:p>
-            <a:pPr>
+            <a:pPr algn="l">
               <a:spcBef>
                 <a:spcPts val="0"/>
               </a:spcBef>
               <a:spcAft>
-                <a:spcPts val="600"/>
+                <a:spcPts val="900"/>
               </a:spcAft>
-              <a:defRPr sz="1400">
+              <a:defRPr sz="1700">
                 <a:solidFill>
                   <a:srgbClr val="023047"/>
                 </a:solidFill>
@@ -5913,14 +5939,14 @@
             </a:r>
           </a:p>
           <a:p>
-            <a:pPr>
+            <a:pPr algn="l">
               <a:spcBef>
                 <a:spcPts val="0"/>
               </a:spcBef>
               <a:spcAft>
-                <a:spcPts val="600"/>
+                <a:spcPts val="900"/>
               </a:spcAft>
-              <a:defRPr sz="1400">
+              <a:defRPr sz="1700">
                 <a:solidFill>
                   <a:srgbClr val="023047"/>
                 </a:solidFill>
@@ -5932,14 +5958,14 @@
             </a:r>
           </a:p>
           <a:p>
-            <a:pPr>
+            <a:pPr algn="l">
               <a:spcBef>
                 <a:spcPts val="0"/>
               </a:spcBef>
               <a:spcAft>
-                <a:spcPts val="600"/>
+                <a:spcPts val="900"/>
               </a:spcAft>
-              <a:defRPr sz="1400">
+              <a:defRPr sz="1700">
                 <a:solidFill>
                   <a:srgbClr val="023047"/>
                 </a:solidFill>
@@ -5951,14 +5977,14 @@
             </a:r>
           </a:p>
           <a:p>
-            <a:pPr>
+            <a:pPr algn="l">
               <a:spcBef>
                 <a:spcPts val="0"/>
               </a:spcBef>
               <a:spcAft>
-                <a:spcPts val="600"/>
+                <a:spcPts val="900"/>
               </a:spcAft>
-              <a:defRPr sz="1400">
+              <a:defRPr sz="1700">
                 <a:solidFill>
                   <a:srgbClr val="023047"/>
                 </a:solidFill>
@@ -5979,11 +6005,13 @@
         </p:nvSpPr>
         <p:spPr>
           <a:xfrm>
-            <a:off x="6278270" y="1508760"/>
-            <a:ext cx="5180990" cy="4663440"/>
+            <a:off x="6278270" y="1554480"/>
+            <a:ext cx="5180990" cy="4709160"/>
           </a:xfrm>
           <a:prstGeom prst="roundRect">
-            <a:avLst/>
+            <a:avLst>
+              <a:gd name="adj" fmla="val 3500"/>
+            </a:avLst>
           </a:prstGeom>
           <a:solidFill>
             <a:srgbClr val="F4F9FC"/>
@@ -6009,17 +6037,17 @@
           </a:fontRef>
         </p:style>
         <p:txBody>
-          <a:bodyPr rtlCol="0" anchor="t" wrap="square" lIns="256032" rIns="256032" tIns="201168" bIns="164592"/>
-          <a:lstStyle/>
-          <a:p>
-            <a:pPr algn="ctr">
+          <a:bodyPr rtlCol="0" anchor="t" wrap="square" lIns="320040" rIns="320040" tIns="274320" bIns="228600"/>
+          <a:lstStyle/>
+          <a:p>
+            <a:pPr algn="l">
               <a:spcBef>
                 <a:spcPts val="0"/>
               </a:spcBef>
               <a:spcAft>
-                <a:spcPts val="1000"/>
+                <a:spcPts val="1200"/>
               </a:spcAft>
-              <a:defRPr sz="1900" b="1">
+              <a:defRPr sz="2300" b="1">
                 <a:solidFill>
                   <a:srgbClr val="023047"/>
                 </a:solidFill>
@@ -6031,14 +6059,14 @@
             </a:r>
           </a:p>
           <a:p>
-            <a:pPr>
+            <a:pPr algn="l">
               <a:spcBef>
                 <a:spcPts val="0"/>
               </a:spcBef>
               <a:spcAft>
-                <a:spcPts val="600"/>
+                <a:spcPts val="900"/>
               </a:spcAft>
-              <a:defRPr sz="1400">
+              <a:defRPr sz="1700">
                 <a:solidFill>
                   <a:srgbClr val="023047"/>
                 </a:solidFill>
@@ -6050,14 +6078,14 @@
             </a:r>
           </a:p>
           <a:p>
-            <a:pPr>
+            <a:pPr algn="l">
               <a:spcBef>
                 <a:spcPts val="0"/>
               </a:spcBef>
               <a:spcAft>
-                <a:spcPts val="600"/>
+                <a:spcPts val="900"/>
               </a:spcAft>
-              <a:defRPr sz="1400">
+              <a:defRPr sz="1700">
                 <a:solidFill>
                   <a:srgbClr val="023047"/>
                 </a:solidFill>
@@ -6069,14 +6097,14 @@
             </a:r>
           </a:p>
           <a:p>
-            <a:pPr>
+            <a:pPr algn="l">
               <a:spcBef>
                 <a:spcPts val="0"/>
               </a:spcBef>
               <a:spcAft>
-                <a:spcPts val="600"/>
+                <a:spcPts val="900"/>
               </a:spcAft>
-              <a:defRPr sz="1400">
+              <a:defRPr sz="1700">
                 <a:solidFill>
                   <a:srgbClr val="023047"/>
                 </a:solidFill>
@@ -6088,14 +6116,14 @@
             </a:r>
           </a:p>
           <a:p>
-            <a:pPr>
+            <a:pPr algn="l">
               <a:spcBef>
                 <a:spcPts val="0"/>
               </a:spcBef>
               <a:spcAft>
-                <a:spcPts val="600"/>
+                <a:spcPts val="900"/>
               </a:spcAft>
-              <a:defRPr sz="1400">
+              <a:defRPr sz="1700">
                 <a:solidFill>
                   <a:srgbClr val="023047"/>
                 </a:solidFill>
@@ -6143,7 +6171,7 @@
         <p:spPr>
           <a:xfrm>
             <a:off x="731520" y="502920"/>
-            <a:ext cx="10728655" cy="777240"/>
+            <a:ext cx="10728655" cy="822960"/>
           </a:xfrm>
           <a:prstGeom prst="rect">
             <a:avLst/>
@@ -6156,8 +6184,8 @@
           </a:bodyPr>
           <a:lstStyle/>
           <a:p>
-            <a:pPr>
-              <a:defRPr sz="3600" b="1">
+            <a:pPr algn="l">
+              <a:defRPr sz="4000" b="1">
                 <a:solidFill>
                   <a:srgbClr val="023047"/>
                 </a:solidFill>
@@ -6179,10 +6207,12 @@
         <p:spPr>
           <a:xfrm>
             <a:off x="731520" y="1554480"/>
-            <a:ext cx="5180990" cy="2194560"/>
+            <a:ext cx="5180990" cy="2240280"/>
           </a:xfrm>
           <a:prstGeom prst="roundRect">
-            <a:avLst/>
+            <a:avLst>
+              <a:gd name="adj" fmla="val 3500"/>
+            </a:avLst>
           </a:prstGeom>
           <a:solidFill>
             <a:srgbClr val="F4F9FC"/>
@@ -6208,17 +6238,17 @@
           </a:fontRef>
         </p:style>
         <p:txBody>
-          <a:bodyPr rtlCol="0" anchor="t" wrap="square" lIns="256032" rIns="256032" tIns="201168" bIns="164592"/>
-          <a:lstStyle/>
-          <a:p>
-            <a:pPr algn="ctr">
+          <a:bodyPr rtlCol="0" anchor="t" wrap="square" lIns="320040" rIns="320040" tIns="274320" bIns="228600"/>
+          <a:lstStyle/>
+          <a:p>
+            <a:pPr algn="l">
               <a:spcBef>
                 <a:spcPts val="0"/>
               </a:spcBef>
               <a:spcAft>
-                <a:spcPts val="1000"/>
+                <a:spcPts val="1200"/>
               </a:spcAft>
-              <a:defRPr sz="1900" b="1">
+              <a:defRPr sz="2200" b="1">
                 <a:solidFill>
                   <a:srgbClr val="023047"/>
                 </a:solidFill>
@@ -6230,14 +6260,14 @@
             </a:r>
           </a:p>
           <a:p>
-            <a:pPr>
+            <a:pPr algn="l">
               <a:spcBef>
                 <a:spcPts val="0"/>
               </a:spcBef>
               <a:spcAft>
-                <a:spcPts val="600"/>
+                <a:spcPts val="900"/>
               </a:spcAft>
-              <a:defRPr sz="1400">
+              <a:defRPr sz="1600">
                 <a:solidFill>
                   <a:srgbClr val="023047"/>
                 </a:solidFill>
@@ -6249,14 +6279,14 @@
             </a:r>
           </a:p>
           <a:p>
-            <a:pPr>
+            <a:pPr algn="l">
               <a:spcBef>
                 <a:spcPts val="0"/>
               </a:spcBef>
               <a:spcAft>
-                <a:spcPts val="600"/>
+                <a:spcPts val="900"/>
               </a:spcAft>
-              <a:defRPr sz="1400">
+              <a:defRPr sz="1600">
                 <a:solidFill>
                   <a:srgbClr val="023047"/>
                 </a:solidFill>
@@ -6278,10 +6308,12 @@
         <p:spPr>
           <a:xfrm>
             <a:off x="6278270" y="1554480"/>
-            <a:ext cx="5180990" cy="2194560"/>
+            <a:ext cx="5180990" cy="2240280"/>
           </a:xfrm>
           <a:prstGeom prst="roundRect">
-            <a:avLst/>
+            <a:avLst>
+              <a:gd name="adj" fmla="val 3500"/>
+            </a:avLst>
           </a:prstGeom>
           <a:solidFill>
             <a:srgbClr val="F4F9FC"/>
@@ -6307,17 +6339,17 @@
           </a:fontRef>
         </p:style>
         <p:txBody>
-          <a:bodyPr rtlCol="0" anchor="t" wrap="square" lIns="256032" rIns="256032" tIns="201168" bIns="164592"/>
-          <a:lstStyle/>
-          <a:p>
-            <a:pPr algn="ctr">
+          <a:bodyPr rtlCol="0" anchor="t" wrap="square" lIns="320040" rIns="320040" tIns="274320" bIns="228600"/>
+          <a:lstStyle/>
+          <a:p>
+            <a:pPr algn="l">
               <a:spcBef>
                 <a:spcPts val="0"/>
               </a:spcBef>
               <a:spcAft>
-                <a:spcPts val="1000"/>
+                <a:spcPts val="1200"/>
               </a:spcAft>
-              <a:defRPr sz="1900" b="1">
+              <a:defRPr sz="2200" b="1">
                 <a:solidFill>
                   <a:srgbClr val="023047"/>
                 </a:solidFill>
@@ -6329,14 +6361,14 @@
             </a:r>
           </a:p>
           <a:p>
-            <a:pPr>
+            <a:pPr algn="l">
               <a:spcBef>
                 <a:spcPts val="0"/>
               </a:spcBef>
               <a:spcAft>
-                <a:spcPts val="600"/>
+                <a:spcPts val="900"/>
               </a:spcAft>
-              <a:defRPr sz="1400">
+              <a:defRPr sz="1600">
                 <a:solidFill>
                   <a:srgbClr val="023047"/>
                 </a:solidFill>
@@ -6348,14 +6380,14 @@
             </a:r>
           </a:p>
           <a:p>
-            <a:pPr>
+            <a:pPr algn="l">
               <a:spcBef>
                 <a:spcPts val="0"/>
               </a:spcBef>
               <a:spcAft>
-                <a:spcPts val="600"/>
+                <a:spcPts val="900"/>
               </a:spcAft>
-              <a:defRPr sz="1400">
+              <a:defRPr sz="1600">
                 <a:solidFill>
                   <a:srgbClr val="023047"/>
                 </a:solidFill>
@@ -6377,10 +6409,12 @@
         <p:spPr>
           <a:xfrm>
             <a:off x="731520" y="4069080"/>
-            <a:ext cx="5180990" cy="2194560"/>
+            <a:ext cx="5180990" cy="2240280"/>
           </a:xfrm>
           <a:prstGeom prst="roundRect">
-            <a:avLst/>
+            <a:avLst>
+              <a:gd name="adj" fmla="val 3500"/>
+            </a:avLst>
           </a:prstGeom>
           <a:solidFill>
             <a:srgbClr val="F4F9FC"/>
@@ -6406,17 +6440,17 @@
           </a:fontRef>
         </p:style>
         <p:txBody>
-          <a:bodyPr rtlCol="0" anchor="t" wrap="square" lIns="256032" rIns="256032" tIns="201168" bIns="164592"/>
-          <a:lstStyle/>
-          <a:p>
-            <a:pPr algn="ctr">
+          <a:bodyPr rtlCol="0" anchor="t" wrap="square" lIns="320040" rIns="320040" tIns="274320" bIns="228600"/>
+          <a:lstStyle/>
+          <a:p>
+            <a:pPr algn="l">
               <a:spcBef>
                 <a:spcPts val="0"/>
               </a:spcBef>
               <a:spcAft>
-                <a:spcPts val="1000"/>
+                <a:spcPts val="1200"/>
               </a:spcAft>
-              <a:defRPr sz="1900" b="1">
+              <a:defRPr sz="2200" b="1">
                 <a:solidFill>
                   <a:srgbClr val="023047"/>
                 </a:solidFill>
@@ -6428,14 +6462,14 @@
             </a:r>
           </a:p>
           <a:p>
-            <a:pPr>
+            <a:pPr algn="l">
               <a:spcBef>
                 <a:spcPts val="0"/>
               </a:spcBef>
               <a:spcAft>
-                <a:spcPts val="600"/>
+                <a:spcPts val="900"/>
               </a:spcAft>
-              <a:defRPr sz="1400">
+              <a:defRPr sz="1600">
                 <a:solidFill>
                   <a:srgbClr val="023047"/>
                 </a:solidFill>
@@ -6447,14 +6481,14 @@
             </a:r>
           </a:p>
           <a:p>
-            <a:pPr>
+            <a:pPr algn="l">
               <a:spcBef>
                 <a:spcPts val="0"/>
               </a:spcBef>
               <a:spcAft>
-                <a:spcPts val="600"/>
+                <a:spcPts val="900"/>
               </a:spcAft>
-              <a:defRPr sz="1400">
+              <a:defRPr sz="1600">
                 <a:solidFill>
                   <a:srgbClr val="023047"/>
                 </a:solidFill>
@@ -6476,10 +6510,12 @@
         <p:spPr>
           <a:xfrm>
             <a:off x="6278270" y="4069080"/>
-            <a:ext cx="5180990" cy="2194560"/>
+            <a:ext cx="5180990" cy="2240280"/>
           </a:xfrm>
           <a:prstGeom prst="roundRect">
-            <a:avLst/>
+            <a:avLst>
+              <a:gd name="adj" fmla="val 3500"/>
+            </a:avLst>
           </a:prstGeom>
           <a:solidFill>
             <a:srgbClr val="F4F9FC"/>
@@ -6505,17 +6541,17 @@
           </a:fontRef>
         </p:style>
         <p:txBody>
-          <a:bodyPr rtlCol="0" anchor="t" wrap="square" lIns="256032" rIns="256032" tIns="201168" bIns="164592"/>
-          <a:lstStyle/>
-          <a:p>
-            <a:pPr algn="ctr">
+          <a:bodyPr rtlCol="0" anchor="t" wrap="square" lIns="320040" rIns="320040" tIns="274320" bIns="228600"/>
+          <a:lstStyle/>
+          <a:p>
+            <a:pPr algn="l">
               <a:spcBef>
                 <a:spcPts val="0"/>
               </a:spcBef>
               <a:spcAft>
-                <a:spcPts val="1000"/>
+                <a:spcPts val="1200"/>
               </a:spcAft>
-              <a:defRPr sz="1900" b="1">
+              <a:defRPr sz="2200" b="1">
                 <a:solidFill>
                   <a:srgbClr val="023047"/>
                 </a:solidFill>
@@ -6527,14 +6563,14 @@
             </a:r>
           </a:p>
           <a:p>
-            <a:pPr>
+            <a:pPr algn="l">
               <a:spcBef>
                 <a:spcPts val="0"/>
               </a:spcBef>
               <a:spcAft>
-                <a:spcPts val="600"/>
+                <a:spcPts val="900"/>
               </a:spcAft>
-              <a:defRPr sz="1400">
+              <a:defRPr sz="1600">
                 <a:solidFill>
                   <a:srgbClr val="023047"/>
                 </a:solidFill>
@@ -6546,14 +6582,14 @@
             </a:r>
           </a:p>
           <a:p>
-            <a:pPr>
+            <a:pPr algn="l">
               <a:spcBef>
                 <a:spcPts val="0"/>
               </a:spcBef>
               <a:spcAft>
-                <a:spcPts val="600"/>
+                <a:spcPts val="900"/>
               </a:spcAft>
-              <a:defRPr sz="1400">
+              <a:defRPr sz="1600">
                 <a:solidFill>
                   <a:srgbClr val="023047"/>
                 </a:solidFill>

</xml_diff>